<commit_message>
Document measurement parallelism in GPU deck
</commit_message>
<xml_diff>
--- a/docs/FPSEID21_TDDFT_GPU_PROGRESS_2026-08-04.pptx
+++ b/docs/FPSEID21_TDDFT_GPU_PROGRESS_2026-08-04.pptx
@@ -2,35 +2,35 @@
 <file path=ppt/presentation.xml><?xml version="1.0" encoding="utf-8"?>
 <p:presentation xmlns:p="http://schemas.openxmlformats.org/presentationml/2006/main">
   <p:sldMasterIdLst>
-    <p:sldMasterId xmlns:r="http://schemas.openxmlformats.org/officeDocument/2006/relationships" id="2147483648" r:id="R2bae8ad1a54e46ec"/>
+    <p:sldMasterId xmlns:r="http://schemas.openxmlformats.org/officeDocument/2006/relationships" id="2147483648" r:id="Rd84b300f15c046e1"/>
   </p:sldMasterIdLst>
   <p:notesMasterIdLst>
-    <p:notesMasterId xmlns:r="http://schemas.openxmlformats.org/officeDocument/2006/relationships" r:id="Rac266d5c641548cc"/>
+    <p:notesMasterId xmlns:r="http://schemas.openxmlformats.org/officeDocument/2006/relationships" r:id="R8b2e53d227a1451f"/>
   </p:notesMasterIdLst>
   <p:sldIdLst>
-    <p:sldId xmlns:r="http://schemas.openxmlformats.org/officeDocument/2006/relationships" id="256" r:id="R1a14c0c5b66f49bc"/>
-    <p:sldId xmlns:r="http://schemas.openxmlformats.org/officeDocument/2006/relationships" id="257" r:id="R87ee3cea5f5840cc"/>
-    <p:sldId xmlns:r="http://schemas.openxmlformats.org/officeDocument/2006/relationships" id="258" r:id="R96d7f6cd13a54121"/>
-    <p:sldId xmlns:r="http://schemas.openxmlformats.org/officeDocument/2006/relationships" id="259" r:id="Ra1373d9464d84eb8"/>
-    <p:sldId xmlns:r="http://schemas.openxmlformats.org/officeDocument/2006/relationships" id="260" r:id="R573fb9eaa5ba4ea9"/>
-    <p:sldId xmlns:r="http://schemas.openxmlformats.org/officeDocument/2006/relationships" id="261" r:id="Rda59278d364440a4"/>
-    <p:sldId xmlns:r="http://schemas.openxmlformats.org/officeDocument/2006/relationships" id="262" r:id="R0f90ad2cc2364174"/>
-    <p:sldId xmlns:r="http://schemas.openxmlformats.org/officeDocument/2006/relationships" id="263" r:id="R976127d901424627"/>
-    <p:sldId xmlns:r="http://schemas.openxmlformats.org/officeDocument/2006/relationships" id="264" r:id="R7c98cb0b1eb24431"/>
-    <p:sldId xmlns:r="http://schemas.openxmlformats.org/officeDocument/2006/relationships" id="265" r:id="Rab26f46e540a4962"/>
-    <p:sldId xmlns:r="http://schemas.openxmlformats.org/officeDocument/2006/relationships" id="266" r:id="R6f124cc10f3646c4"/>
-    <p:sldId xmlns:r="http://schemas.openxmlformats.org/officeDocument/2006/relationships" id="267" r:id="R70bc8c8d47c641f5"/>
-    <p:sldId xmlns:r="http://schemas.openxmlformats.org/officeDocument/2006/relationships" id="268" r:id="R57745c9a16aa48d7"/>
-    <p:sldId xmlns:r="http://schemas.openxmlformats.org/officeDocument/2006/relationships" id="269" r:id="Ra77901b2c2fd4d82"/>
-    <p:sldId xmlns:r="http://schemas.openxmlformats.org/officeDocument/2006/relationships" id="270" r:id="Rd00eaecd49da4e62"/>
-    <p:sldId xmlns:r="http://schemas.openxmlformats.org/officeDocument/2006/relationships" id="271" r:id="R8e0259d6d8464275"/>
-    <p:sldId xmlns:r="http://schemas.openxmlformats.org/officeDocument/2006/relationships" id="272" r:id="R1642338c777a4f48"/>
-    <p:sldId xmlns:r="http://schemas.openxmlformats.org/officeDocument/2006/relationships" id="273" r:id="R0ad0ad3f777443cb"/>
-    <p:sldId xmlns:r="http://schemas.openxmlformats.org/officeDocument/2006/relationships" id="274" r:id="R188f3cd066f54003"/>
-    <p:sldId xmlns:r="http://schemas.openxmlformats.org/officeDocument/2006/relationships" id="275" r:id="R30e4e98b22874c4c"/>
-    <p:sldId xmlns:r="http://schemas.openxmlformats.org/officeDocument/2006/relationships" id="276" r:id="Rf5a273c465004a42"/>
-    <p:sldId xmlns:r="http://schemas.openxmlformats.org/officeDocument/2006/relationships" id="277" r:id="R8dce5cb6b6f04d08"/>
-    <p:sldId xmlns:r="http://schemas.openxmlformats.org/officeDocument/2006/relationships" id="278" r:id="R0daa3e602902404c"/>
+    <p:sldId xmlns:r="http://schemas.openxmlformats.org/officeDocument/2006/relationships" id="256" r:id="Re543578fb43f4fd2"/>
+    <p:sldId xmlns:r="http://schemas.openxmlformats.org/officeDocument/2006/relationships" id="257" r:id="R9d1c8c96d0a542d4"/>
+    <p:sldId xmlns:r="http://schemas.openxmlformats.org/officeDocument/2006/relationships" id="258" r:id="R2c7d65bd2b354bbf"/>
+    <p:sldId xmlns:r="http://schemas.openxmlformats.org/officeDocument/2006/relationships" id="259" r:id="R63a7fe99b4a24ad2"/>
+    <p:sldId xmlns:r="http://schemas.openxmlformats.org/officeDocument/2006/relationships" id="260" r:id="R89b3ed23abc649cf"/>
+    <p:sldId xmlns:r="http://schemas.openxmlformats.org/officeDocument/2006/relationships" id="261" r:id="R21d8befc973d4727"/>
+    <p:sldId xmlns:r="http://schemas.openxmlformats.org/officeDocument/2006/relationships" id="262" r:id="R5f7616983bcb4296"/>
+    <p:sldId xmlns:r="http://schemas.openxmlformats.org/officeDocument/2006/relationships" id="263" r:id="Ra2727ea1bb214e07"/>
+    <p:sldId xmlns:r="http://schemas.openxmlformats.org/officeDocument/2006/relationships" id="264" r:id="Ra74742aac64b43d8"/>
+    <p:sldId xmlns:r="http://schemas.openxmlformats.org/officeDocument/2006/relationships" id="265" r:id="R8a87c4285cf24616"/>
+    <p:sldId xmlns:r="http://schemas.openxmlformats.org/officeDocument/2006/relationships" id="266" r:id="Rc67dcd43c9ad40b0"/>
+    <p:sldId xmlns:r="http://schemas.openxmlformats.org/officeDocument/2006/relationships" id="267" r:id="Rd94ed3a30fe24361"/>
+    <p:sldId xmlns:r="http://schemas.openxmlformats.org/officeDocument/2006/relationships" id="268" r:id="R3ee537c445644088"/>
+    <p:sldId xmlns:r="http://schemas.openxmlformats.org/officeDocument/2006/relationships" id="269" r:id="Rf1c2f76893894e4e"/>
+    <p:sldId xmlns:r="http://schemas.openxmlformats.org/officeDocument/2006/relationships" id="270" r:id="R362a0e8f71944713"/>
+    <p:sldId xmlns:r="http://schemas.openxmlformats.org/officeDocument/2006/relationships" id="271" r:id="R006bd91f05b345e3"/>
+    <p:sldId xmlns:r="http://schemas.openxmlformats.org/officeDocument/2006/relationships" id="272" r:id="R50f419a1bf8043e0"/>
+    <p:sldId xmlns:r="http://schemas.openxmlformats.org/officeDocument/2006/relationships" id="273" r:id="R5e259ad7a62b4c17"/>
+    <p:sldId xmlns:r="http://schemas.openxmlformats.org/officeDocument/2006/relationships" id="274" r:id="Rd986404687754470"/>
+    <p:sldId xmlns:r="http://schemas.openxmlformats.org/officeDocument/2006/relationships" id="275" r:id="Rabb45d10efd849fe"/>
+    <p:sldId xmlns:r="http://schemas.openxmlformats.org/officeDocument/2006/relationships" id="276" r:id="Rfeb407a06aa14159"/>
+    <p:sldId xmlns:r="http://schemas.openxmlformats.org/officeDocument/2006/relationships" id="277" r:id="R015e66333d304437"/>
+    <p:sldId xmlns:r="http://schemas.openxmlformats.org/officeDocument/2006/relationships" id="278" r:id="Rdac552a3fe444114"/>
   </p:sldIdLst>
   <p:sldSz cx="12192000" cy="6858000"/>
   <p:notesSz cx="6858000" cy="9144000"/>
@@ -2552,7 +2552,7 @@
   </p:cSld>
   <p:clrMap bg1="lt1" tx1="dk1" bg2="lt2" tx2="dk2" accent1="accent1" accent2="accent2" accent3="accent3" accent4="accent4" accent5="accent5" accent6="accent6" hlink="hlink" folHlink="folHlink"/>
   <p:sldLayoutIdLst>
-    <p:sldLayoutId xmlns:r="http://schemas.openxmlformats.org/officeDocument/2006/relationships" id="2147483649" r:id="Rd37bf53f555e4c4d"/>
+    <p:sldLayoutId xmlns:r="http://schemas.openxmlformats.org/officeDocument/2006/relationships" id="2147483649" r:id="Rd757b647ee26404c"/>
   </p:sldLayoutIdLst>
   <p:txStyles>
     <p:titleStyle>
@@ -4721,7 +4721,7 @@
         </p:xfrm>
         <a:graphic xmlns:a="http://schemas.openxmlformats.org/drawingml/2006/main">
           <a:graphicData uri="http://schemas.openxmlformats.org/drawingml/2006/chart">
-            <c:chart xmlns:r="http://schemas.openxmlformats.org/officeDocument/2006/relationships" xmlns:c="http://schemas.openxmlformats.org/drawingml/2006/chart" r:id="R786cf734e2fd41f9"/>
+            <c:chart xmlns:r="http://schemas.openxmlformats.org/officeDocument/2006/relationships" xmlns:c="http://schemas.openxmlformats.org/drawingml/2006/chart" r:id="Re1154cb923fb454a"/>
           </a:graphicData>
         </a:graphic>
       </p:graphicFrame>
@@ -5199,7 +5199,7 @@
                             <a:srgbClr val="1F2937"/>
                           </a:solidFill>
                         </a:rPr>
-                        <a:t>OpenACC/cuFFT、1 GPU / 1 MPI</a:t>
+                        <a:t>OpenACC/cuFFT、1 GPU × 1 MPI × OMP 1</a:t>
                       </a:r>
                     </a:p>
                   </a:txBody>
@@ -5286,7 +5286,7 @@
                             <a:srgbClr val="1F2937"/>
                           </a:solidFill>
                         </a:rPr>
-                        <a:t>OpenACC/cuFFT、1 GPU / 1 MPI</a:t>
+                        <a:t>OpenACC/cuFFT、1 GPU × 1 MPI × OMP 1</a:t>
                       </a:r>
                     </a:p>
                   </a:txBody>
@@ -5373,7 +5373,7 @@
                             <a:srgbClr val="1F2937"/>
                           </a:solidFill>
                         </a:rPr>
-                        <a:t>ifx/mpiifx、32 MPI × 8 OpenMP</a:t>
+                        <a:t>ifx/mpiifx、32 MPI × 8 OMP = 256 threads</a:t>
                       </a:r>
                     </a:p>
                   </a:txBody>
@@ -5532,7 +5532,7 @@
                   <a:srgbClr val="1F2937"/>
                 </a:solidFill>
               </a:rPr>
-              <a:t>• x86は256 CPUコアを使用しており、1 GPUとの装置性能の直接比較ではない</a:t>
+              <a:t>• x86は32 ranks × 8 threads/rank = 256 threads。1 GPUとの装置性能の直接比較ではない</a:t>
             </a:r>
           </a:p>
         </p:txBody>
@@ -6574,7 +6574,7 @@
                   <a:srgbClr val="1769AA"/>
                 </a:solidFill>
               </a:rPr>
-              <a:t>性能が伸びにくい根拠</a:t>
+              <a:t>性能が伸びにくい根拠｜1 GPU × 1 MPI rank × OMP 1</a:t>
             </a:r>
           </a:p>
         </p:txBody>
@@ -6823,7 +6823,7 @@
         </p:xfrm>
         <a:graphic xmlns:a="http://schemas.openxmlformats.org/drawingml/2006/main">
           <a:graphicData uri="http://schemas.openxmlformats.org/drawingml/2006/chart">
-            <c:chart xmlns:r="http://schemas.openxmlformats.org/officeDocument/2006/relationships" xmlns:c="http://schemas.openxmlformats.org/drawingml/2006/chart" r:id="Re7a4ef2fc99249eb"/>
+            <c:chart xmlns:r="http://schemas.openxmlformats.org/officeDocument/2006/relationships" xmlns:c="http://schemas.openxmlformats.org/drawingml/2006/chart" r:id="Ra34f5c84f0324b84"/>
           </a:graphicData>
         </a:graphic>
       </p:graphicFrame>
@@ -8224,7 +8224,7 @@
                             <a:srgbClr val="1F2937"/>
                           </a:solidFill>
                         </a:rPr>
-                        <a:t>cc80、1 GPU / 1 MPI、diagnostic OFF</a:t>
+                        <a:t>cc80、1 GPU × 1 MPI × OMP 1、diagnostic OFF</a:t>
                       </a:r>
                     </a:p>
                   </a:txBody>
@@ -8294,7 +8294,7 @@
                             <a:srgbClr val="1F2937"/>
                           </a:solidFill>
                         </a:rPr>
-                        <a:t>cc90、1 GPU / 1 MPI、diagnostic OFF</a:t>
+                        <a:t>cc90、1 GPU × 1 MPI × OMP 1、diagnostic OFF</a:t>
                       </a:r>
                     </a:p>
                   </a:txBody>
@@ -8364,7 +8364,7 @@
                             <a:srgbClr val="1F2937"/>
                           </a:solidFill>
                         </a:rPr>
-                        <a:t>ifx/mpiifx、32 MPI × 8 OpenMP</a:t>
+                        <a:t>ifx/mpiifx、32 MPI × 8 OMP = 256 threads</a:t>
                       </a:r>
                     </a:p>
                   </a:txBody>
@@ -10255,7 +10255,7 @@
                   <a:srgbClr val="667085"/>
                 </a:solidFill>
               </a:rPr>
-              <a:t>A100正式baseline</a:t>
+              <a:t>A100｜1 GPU × 1 MPI × OMP 1</a:t>
             </a:r>
           </a:p>
         </p:txBody>
@@ -10357,7 +10357,7 @@
                   <a:srgbClr val="667085"/>
                 </a:solidFill>
               </a:rPr>
-              <a:t>H100独立baseline</a:t>
+              <a:t>H100｜1 GPU × 1 MPI × OMP 1</a:t>
             </a:r>
           </a:p>
         </p:txBody>
@@ -10579,7 +10579,7 @@
                   <a:srgbClr val="1F2937"/>
                 </a:solidFill>
               </a:rPr>
-              <a:t>• CPU/FFTW fallbackと1 GPU / 1 MPI rankの検証経路を維持</a:t>
+              <a:t>• GPU: 1 GPU × 1 MPI rank × OMP 1／x86: 32 MPI × 8 OMP = 256 threads</a:t>
             </a:r>
           </a:p>
           <a:p xmlns:a="http://schemas.openxmlformats.org/drawingml/2006/main">

</xml_diff>